<commit_message>
Redesign all 25 deck title slides: rich full-bleed covers, a distinct direction per deck
Replace the plain rebuilt title slides (which read as low-effort) with designed
full-bleed covers. Eight distinct title directions (emblem, left-panel, bottom-band,
dark-ring, inset-frame, giant-monogram watermark, diagonal wedge, split-horizontal),
each deck a unique (title-direction, content-archetype) pairing on its own colour,
font and project monogram. Content slides unchanged (verified intact after the
title/content refactor); Nemi's and Uday's decks re-verified end to end.
</commit_message>
<xml_diff>
--- a/ppt/24288853_aquaculture-fish-farm.pptx
+++ b/ppt/24288853_aquaculture-fish-farm.pptx
@@ -3101,8 +3101,8 @@
         </p:nvSpPr>
         <p:spPr>
           <a:xfrm>
-            <a:off x="0" y="0"/>
-            <a:ext cx="4114800" cy="6858000"/>
+            <a:off x="-91440" y="-91440"/>
+            <a:ext cx="12435840" cy="7040880"/>
           </a:xfrm>
           <a:prstGeom prst="rect">
             <a:avLst/>
@@ -3139,55 +3139,20 @@
       </p:sp>
       <p:sp>
         <p:nvSpPr>
-          <p:cNvPr id="3" name="TextBox 2"/>
-          <p:cNvSpPr txBox="1"/>
-          <p:nvPr/>
-        </p:nvSpPr>
-        <p:spPr>
-          <a:xfrm>
-            <a:off x="502920" y="1920240"/>
-            <a:ext cx="3291840" cy="2743200"/>
-          </a:xfrm>
-          <a:prstGeom prst="rect">
-            <a:avLst/>
-          </a:prstGeom>
-          <a:noFill/>
-        </p:spPr>
-        <p:txBody>
-          <a:bodyPr wrap="square" anchor="t">
-            <a:spAutoFit/>
-          </a:bodyPr>
-          <a:lstStyle/>
-          <a:p>
-            <a:pPr algn="l"/>
-            <a:r>
-              <a:rPr sz="2700" b="1">
-                <a:solidFill>
-                  <a:srgbClr val="FFFFFF"/>
-                </a:solidFill>
-                <a:latin typeface="Corbel"/>
-              </a:rPr>
-              <a:t>Aquaculture Fish Farm Water Quality</a:t>
-            </a:r>
-          </a:p>
-        </p:txBody>
-      </p:sp>
-      <p:sp>
-        <p:nvSpPr>
-          <p:cNvPr id="4" name="Rectangle 3"/>
+          <p:cNvPr id="3" name="Rectangle 2"/>
           <p:cNvSpPr/>
           <p:nvPr/>
         </p:nvSpPr>
         <p:spPr>
           <a:xfrm>
-            <a:off x="530352" y="4480560"/>
-            <a:ext cx="1554480" cy="45720"/>
+            <a:off x="0" y="0"/>
+            <a:ext cx="4297680" cy="6858000"/>
           </a:xfrm>
           <a:prstGeom prst="rect">
             <a:avLst/>
           </a:prstGeom>
           <a:solidFill>
-            <a:srgbClr val="FFFFFF"/>
+            <a:srgbClr val="155562"/>
           </a:solidFill>
           <a:ln>
             <a:noFill/>
@@ -3218,14 +3183,58 @@
       </p:sp>
       <p:sp>
         <p:nvSpPr>
+          <p:cNvPr id="4" name="Oval 3"/>
+          <p:cNvSpPr/>
+          <p:nvPr/>
+        </p:nvSpPr>
+        <p:spPr>
+          <a:xfrm>
+            <a:off x="1463040" y="1325880"/>
+            <a:ext cx="1371600" cy="1371600"/>
+          </a:xfrm>
+          <a:prstGeom prst="ellipse">
+            <a:avLst/>
+          </a:prstGeom>
+          <a:solidFill>
+            <a:srgbClr val="FFFFFF"/>
+          </a:solidFill>
+          <a:ln>
+            <a:noFill/>
+          </a:ln>
+          <a:effectLst/>
+        </p:spPr>
+        <p:style>
+          <a:lnRef idx="1">
+            <a:schemeClr val="accent1"/>
+          </a:lnRef>
+          <a:fillRef idx="3">
+            <a:schemeClr val="accent1"/>
+          </a:fillRef>
+          <a:effectRef idx="2">
+            <a:schemeClr val="accent1"/>
+          </a:effectRef>
+          <a:fontRef idx="minor">
+            <a:schemeClr val="lt1"/>
+          </a:fontRef>
+        </p:style>
+        <p:txBody>
+          <a:bodyPr rtlCol="0" anchor="ctr"/>
+          <a:lstStyle/>
+          <a:p>
+            <a:pPr algn="ctr"/>
+          </a:p>
+        </p:txBody>
+      </p:sp>
+      <p:sp>
+        <p:nvSpPr>
           <p:cNvPr id="5" name="TextBox 4"/>
           <p:cNvSpPr txBox="1"/>
           <p:nvPr/>
         </p:nvSpPr>
         <p:spPr>
           <a:xfrm>
-            <a:off x="4663440" y="2286000"/>
-            <a:ext cx="6492240" cy="2926080"/>
+            <a:off x="1463040" y="1325880"/>
+            <a:ext cx="1371600" cy="1371600"/>
           </a:xfrm>
           <a:prstGeom prst="rect">
             <a:avLst/>
@@ -3233,6 +3242,41 @@
           <a:noFill/>
         </p:spPr>
         <p:txBody>
+          <a:bodyPr wrap="none" anchor="ctr">
+            <a:spAutoFit/>
+          </a:bodyPr>
+          <a:lstStyle/>
+          <a:p>
+            <a:pPr algn="ctr"/>
+            <a:r>
+              <a:rPr sz="4500" b="1">
+                <a:solidFill>
+                  <a:srgbClr val="155562"/>
+                </a:solidFill>
+                <a:latin typeface="Corbel"/>
+              </a:rPr>
+              <a:t>AF</a:t>
+            </a:r>
+          </a:p>
+        </p:txBody>
+      </p:sp>
+      <p:sp>
+        <p:nvSpPr>
+          <p:cNvPr id="6" name="TextBox 5"/>
+          <p:cNvSpPr txBox="1"/>
+          <p:nvPr/>
+        </p:nvSpPr>
+        <p:spPr>
+          <a:xfrm>
+            <a:off x="457200" y="3108960"/>
+            <a:ext cx="3383280" cy="2743200"/>
+          </a:xfrm>
+          <a:prstGeom prst="rect">
+            <a:avLst/>
+          </a:prstGeom>
+          <a:noFill/>
+        </p:spPr>
+        <p:txBody>
           <a:bodyPr wrap="square" anchor="t">
             <a:spAutoFit/>
           </a:bodyPr>
@@ -3240,21 +3284,79 @@
           <a:p>
             <a:pPr algn="l"/>
             <a:r>
-              <a:rPr sz="1800" b="0">
-                <a:solidFill>
-                  <a:srgbClr val="5C655F"/>
+              <a:rPr sz="1500" b="0" i="1">
+                <a:solidFill>
+                  <a:srgbClr val="DDEBED"/>
                 </a:solidFill>
                 <a:latin typeface="Verdana"/>
               </a:rPr>
               <a:t>Continuous two-pond monitoring: fog aggregation at the edge, serverless ingestion in the cloud, deployed live on AWS.</a:t>
             </a:r>
           </a:p>
+        </p:txBody>
+      </p:sp>
+      <p:sp>
+        <p:nvSpPr>
+          <p:cNvPr id="7" name="TextBox 6"/>
+          <p:cNvSpPr txBox="1"/>
+          <p:nvPr/>
+        </p:nvSpPr>
+        <p:spPr>
+          <a:xfrm>
+            <a:off x="4754880" y="1737360"/>
+            <a:ext cx="7040880" cy="2194560"/>
+          </a:xfrm>
+          <a:prstGeom prst="rect">
+            <a:avLst/>
+          </a:prstGeom>
+          <a:noFill/>
+        </p:spPr>
+        <p:txBody>
+          <a:bodyPr wrap="square" anchor="ctr">
+            <a:spAutoFit/>
+          </a:bodyPr>
+          <a:lstStyle/>
           <a:p>
             <a:pPr algn="l"/>
             <a:r>
-              <a:rPr sz="1700" b="1">
-                <a:solidFill>
-                  <a:srgbClr val="232A26"/>
+              <a:rPr sz="3200" b="1" i="0">
+                <a:solidFill>
+                  <a:srgbClr val="FFFFFF"/>
+                </a:solidFill>
+                <a:latin typeface="Corbel"/>
+              </a:rPr>
+              <a:t>Aquaculture Fish Farm Water Quality</a:t>
+            </a:r>
+          </a:p>
+        </p:txBody>
+      </p:sp>
+      <p:sp>
+        <p:nvSpPr>
+          <p:cNvPr id="8" name="TextBox 7"/>
+          <p:cNvSpPr txBox="1"/>
+          <p:nvPr/>
+        </p:nvSpPr>
+        <p:spPr>
+          <a:xfrm>
+            <a:off x="4754880" y="4297680"/>
+            <a:ext cx="6858000" cy="1645920"/>
+          </a:xfrm>
+          <a:prstGeom prst="rect">
+            <a:avLst/>
+          </a:prstGeom>
+          <a:noFill/>
+        </p:spPr>
+        <p:txBody>
+          <a:bodyPr wrap="square" anchor="t">
+            <a:spAutoFit/>
+          </a:bodyPr>
+          <a:lstStyle/>
+          <a:p>
+            <a:pPr algn="l"/>
+            <a:r>
+              <a:rPr sz="1700" b="1" i="0">
+                <a:solidFill>
+                  <a:srgbClr val="FFFFFF"/>
                 </a:solidFill>
                 <a:latin typeface="Verdana"/>
               </a:rPr>
@@ -3264,9 +3366,9 @@
           <a:p>
             <a:pPr algn="l"/>
             <a:r>
-              <a:rPr sz="1300" b="0">
-                <a:solidFill>
-                  <a:srgbClr val="5C655F"/>
+              <a:rPr sz="1300" b="0" i="0">
+                <a:solidFill>
+                  <a:srgbClr val="BBD7DC"/>
                 </a:solidFill>
                 <a:latin typeface="Verdana"/>
               </a:rPr>
@@ -3276,25 +3378,25 @@
           <a:p>
             <a:pPr algn="l"/>
             <a:r>
-              <a:rPr sz="1300" b="0">
-                <a:solidFill>
-                  <a:srgbClr val="5C655F"/>
+              <a:rPr sz="1250" b="0" i="0">
+                <a:solidFill>
+                  <a:srgbClr val="BBD7DC"/>
                 </a:solidFill>
                 <a:latin typeface="Verdana"/>
               </a:rPr>
-              <a:t>MSc in Cloud Computing</a:t>
+              <a:t>MSc in Cloud Computing   ·   Fog and Edge Computing (H9FECC)</a:t>
             </a:r>
           </a:p>
           <a:p>
             <a:pPr algn="l"/>
             <a:r>
-              <a:rPr sz="1300" b="0">
-                <a:solidFill>
-                  <a:srgbClr val="5C655F"/>
+              <a:rPr sz="1250" b="0" i="0">
+                <a:solidFill>
+                  <a:srgbClr val="BBD7DC"/>
                 </a:solidFill>
                 <a:latin typeface="Verdana"/>
               </a:rPr>
-              <a:t>Fog and Edge Computing (H9FECC), National College of Ireland</a:t>
+              <a:t>National College of Ireland</a:t>
             </a:r>
           </a:p>
         </p:txBody>
@@ -3521,7 +3623,7 @@
           <a:p>
             <a:pPr algn="l"/>
             <a:r>
-              <a:rPr sz="1400" b="1">
+              <a:rPr sz="1400" b="1" i="0">
                 <a:solidFill>
                   <a:srgbClr val="FFFFFF"/>
                 </a:solidFill>
@@ -3770,7 +3872,7 @@
           <a:p>
             <a:pPr algn="l"/>
             <a:r>
-              <a:rPr sz="1400" b="1">
+              <a:rPr sz="1400" b="1" i="0">
                 <a:solidFill>
                   <a:srgbClr val="FFFFFF"/>
                 </a:solidFill>
@@ -4027,7 +4129,7 @@
           <a:p>
             <a:pPr algn="l"/>
             <a:r>
-              <a:rPr sz="1400" b="1">
+              <a:rPr sz="1400" b="1" i="0">
                 <a:solidFill>
                   <a:srgbClr val="FFFFFF"/>
                 </a:solidFill>
@@ -4316,7 +4418,7 @@
           <a:p>
             <a:pPr algn="l"/>
             <a:r>
-              <a:rPr sz="1400" b="1">
+              <a:rPr sz="1400" b="1" i="0">
                 <a:solidFill>
                   <a:srgbClr val="FFFFFF"/>
                 </a:solidFill>
@@ -4565,7 +4667,7 @@
           <a:p>
             <a:pPr algn="l"/>
             <a:r>
-              <a:rPr sz="1400" b="1">
+              <a:rPr sz="1400" b="1" i="0">
                 <a:solidFill>
                   <a:srgbClr val="FFFFFF"/>
                 </a:solidFill>

</xml_diff>

<commit_message>
Redesign all 25 deck covers: remove the circular monogram/emblem badge from every title direction; covers now stand on layout, colour and typography alone
</commit_message>
<xml_diff>
--- a/ppt/24288853_aquaculture-fish-farm.pptx
+++ b/ppt/24288853_aquaculture-fish-farm.pptx
@@ -3183,58 +3183,14 @@
       </p:sp>
       <p:sp>
         <p:nvSpPr>
-          <p:cNvPr id="4" name="Oval 3"/>
-          <p:cNvSpPr/>
+          <p:cNvPr id="4" name="TextBox 3"/>
+          <p:cNvSpPr txBox="1"/>
           <p:nvPr/>
         </p:nvSpPr>
         <p:spPr>
           <a:xfrm>
-            <a:off x="1463040" y="1325880"/>
-            <a:ext cx="1371600" cy="1371600"/>
-          </a:xfrm>
-          <a:prstGeom prst="ellipse">
-            <a:avLst/>
-          </a:prstGeom>
-          <a:solidFill>
-            <a:srgbClr val="FFFFFF"/>
-          </a:solidFill>
-          <a:ln>
-            <a:noFill/>
-          </a:ln>
-          <a:effectLst/>
-        </p:spPr>
-        <p:style>
-          <a:lnRef idx="1">
-            <a:schemeClr val="accent1"/>
-          </a:lnRef>
-          <a:fillRef idx="3">
-            <a:schemeClr val="accent1"/>
-          </a:fillRef>
-          <a:effectRef idx="2">
-            <a:schemeClr val="accent1"/>
-          </a:effectRef>
-          <a:fontRef idx="minor">
-            <a:schemeClr val="lt1"/>
-          </a:fontRef>
-        </p:style>
-        <p:txBody>
-          <a:bodyPr rtlCol="0" anchor="ctr"/>
-          <a:lstStyle/>
-          <a:p>
-            <a:pPr algn="ctr"/>
-          </a:p>
-        </p:txBody>
-      </p:sp>
-      <p:sp>
-        <p:nvSpPr>
-          <p:cNvPr id="5" name="TextBox 4"/>
-          <p:cNvSpPr txBox="1"/>
-          <p:nvPr/>
-        </p:nvSpPr>
-        <p:spPr>
-          <a:xfrm>
-            <a:off x="1463040" y="1325880"/>
-            <a:ext cx="1371600" cy="1371600"/>
+            <a:off x="457200" y="1920240"/>
+            <a:ext cx="3383280" cy="3017520"/>
           </a:xfrm>
           <a:prstGeom prst="rect">
             <a:avLst/>
@@ -3242,34 +3198,34 @@
           <a:noFill/>
         </p:spPr>
         <p:txBody>
-          <a:bodyPr wrap="none" anchor="ctr">
+          <a:bodyPr wrap="square" anchor="ctr">
             <a:spAutoFit/>
           </a:bodyPr>
           <a:lstStyle/>
           <a:p>
-            <a:pPr algn="ctr"/>
-            <a:r>
-              <a:rPr sz="4500" b="1">
-                <a:solidFill>
-                  <a:srgbClr val="155562"/>
-                </a:solidFill>
-                <a:latin typeface="Corbel"/>
+            <a:pPr algn="l"/>
+            <a:r>
+              <a:rPr sz="1600" b="0" i="1">
+                <a:solidFill>
+                  <a:srgbClr val="DDEBED"/>
+                </a:solidFill>
+                <a:latin typeface="Verdana"/>
               </a:rPr>
-              <a:t>AF</a:t>
-            </a:r>
-          </a:p>
-        </p:txBody>
-      </p:sp>
-      <p:sp>
-        <p:nvSpPr>
-          <p:cNvPr id="6" name="TextBox 5"/>
+              <a:t>Continuous two-pond monitoring: fog aggregation at the edge, serverless ingestion in the cloud, deployed live on AWS.</a:t>
+            </a:r>
+          </a:p>
+        </p:txBody>
+      </p:sp>
+      <p:sp>
+        <p:nvSpPr>
+          <p:cNvPr id="5" name="TextBox 4"/>
           <p:cNvSpPr txBox="1"/>
           <p:nvPr/>
         </p:nvSpPr>
         <p:spPr>
           <a:xfrm>
-            <a:off x="457200" y="3108960"/>
-            <a:ext cx="3383280" cy="2743200"/>
+            <a:off x="4754880" y="1783080"/>
+            <a:ext cx="7040880" cy="2377440"/>
           </a:xfrm>
           <a:prstGeom prst="rect">
             <a:avLst/>
@@ -3277,41 +3233,6 @@
           <a:noFill/>
         </p:spPr>
         <p:txBody>
-          <a:bodyPr wrap="square" anchor="t">
-            <a:spAutoFit/>
-          </a:bodyPr>
-          <a:lstStyle/>
-          <a:p>
-            <a:pPr algn="l"/>
-            <a:r>
-              <a:rPr sz="1500" b="0" i="1">
-                <a:solidFill>
-                  <a:srgbClr val="DDEBED"/>
-                </a:solidFill>
-                <a:latin typeface="Verdana"/>
-              </a:rPr>
-              <a:t>Continuous two-pond monitoring: fog aggregation at the edge, serverless ingestion in the cloud, deployed live on AWS.</a:t>
-            </a:r>
-          </a:p>
-        </p:txBody>
-      </p:sp>
-      <p:sp>
-        <p:nvSpPr>
-          <p:cNvPr id="7" name="TextBox 6"/>
-          <p:cNvSpPr txBox="1"/>
-          <p:nvPr/>
-        </p:nvSpPr>
-        <p:spPr>
-          <a:xfrm>
-            <a:off x="4754880" y="1737360"/>
-            <a:ext cx="7040880" cy="2194560"/>
-          </a:xfrm>
-          <a:prstGeom prst="rect">
-            <a:avLst/>
-          </a:prstGeom>
-          <a:noFill/>
-        </p:spPr>
-        <p:txBody>
           <a:bodyPr wrap="square" anchor="ctr">
             <a:spAutoFit/>
           </a:bodyPr>
@@ -3332,13 +3253,13 @@
       </p:sp>
       <p:sp>
         <p:nvSpPr>
-          <p:cNvPr id="8" name="TextBox 7"/>
+          <p:cNvPr id="6" name="TextBox 5"/>
           <p:cNvSpPr txBox="1"/>
           <p:nvPr/>
         </p:nvSpPr>
         <p:spPr>
           <a:xfrm>
-            <a:off x="4754880" y="4297680"/>
+            <a:off x="4754880" y="4434840"/>
             <a:ext cx="6858000" cy="1645920"/>
           </a:xfrm>
           <a:prstGeom prst="rect">

</xml_diff>

<commit_message>
Ensure no two decks share a theme: ΔE colour audit across all archetype+cover groups; move bridge->underline, retail/water->plain, industrial->diagonal (dark now marine-only); recolour smart-city/smart-building/parking/transit/elevator/cold-chain/aquaculture to spread the palette. 0 collisions at ΔE<20
</commit_message>
<xml_diff>
--- a/ppt/24288853_aquaculture-fish-farm.pptx
+++ b/ppt/24288853_aquaculture-fish-farm.pptx
@@ -3108,7 +3108,7 @@
             <a:avLst/>
           </a:prstGeom>
           <a:solidFill>
-            <a:srgbClr val="1F7A8C"/>
+            <a:srgbClr val="0F8A86"/>
           </a:solidFill>
           <a:ln>
             <a:noFill/>
@@ -3152,7 +3152,7 @@
             <a:avLst/>
           </a:prstGeom>
           <a:solidFill>
-            <a:srgbClr val="155562"/>
+            <a:srgbClr val="0A605D"/>
           </a:solidFill>
           <a:ln>
             <a:noFill/>
@@ -3207,7 +3207,7 @@
             <a:r>
               <a:rPr sz="1600" b="0" i="1">
                 <a:solidFill>
-                  <a:srgbClr val="DDEBED"/>
+                  <a:srgbClr val="DBEDEC"/>
                 </a:solidFill>
                 <a:latin typeface="Verdana"/>
               </a:rPr>
@@ -3289,7 +3289,7 @@
             <a:r>
               <a:rPr sz="1300" b="0" i="0">
                 <a:solidFill>
-                  <a:srgbClr val="BBD7DC"/>
+                  <a:srgbClr val="B7DBDA"/>
                 </a:solidFill>
                 <a:latin typeface="Verdana"/>
               </a:rPr>
@@ -3301,7 +3301,7 @@
             <a:r>
               <a:rPr sz="1250" b="0" i="0">
                 <a:solidFill>
-                  <a:srgbClr val="BBD7DC"/>
+                  <a:srgbClr val="B7DBDA"/>
                 </a:solidFill>
                 <a:latin typeface="Verdana"/>
               </a:rPr>
@@ -3313,7 +3313,7 @@
             <a:r>
               <a:rPr sz="1250" b="0" i="0">
                 <a:solidFill>
-                  <a:srgbClr val="BBD7DC"/>
+                  <a:srgbClr val="B7DBDA"/>
                 </a:solidFill>
                 <a:latin typeface="Verdana"/>
               </a:rPr>
@@ -3355,7 +3355,7 @@
             <a:avLst/>
           </a:prstGeom>
           <a:solidFill>
-            <a:srgbClr val="1F7A8C"/>
+            <a:srgbClr val="0F8A86"/>
           </a:solidFill>
           <a:ln>
             <a:noFill/>
@@ -3511,7 +3511,7 @@
             <a:r>
               <a:rPr sz="1700" b="1">
                 <a:solidFill>
-                  <a:srgbClr val="1F7A8C"/>
+                  <a:srgbClr val="0F8A86"/>
                 </a:solidFill>
                 <a:latin typeface="Verdana"/>
               </a:rPr>
@@ -3588,7 +3588,7 @@
             <a:avLst/>
           </a:prstGeom>
           <a:solidFill>
-            <a:srgbClr val="1F7A8C"/>
+            <a:srgbClr val="0F8A86"/>
           </a:solidFill>
           <a:ln>
             <a:noFill/>
@@ -3680,7 +3680,7 @@
             <a:r>
               <a:rPr sz="1500" b="1">
                 <a:solidFill>
-                  <a:srgbClr val="1F7A8C"/>
+                  <a:srgbClr val="0F8A86"/>
                 </a:solidFill>
                 <a:latin typeface="Verdana"/>
               </a:rPr>
@@ -3760,7 +3760,7 @@
             <a:r>
               <a:rPr sz="1500" b="1">
                 <a:solidFill>
-                  <a:srgbClr val="1F7A8C"/>
+                  <a:srgbClr val="0F8A86"/>
                 </a:solidFill>
                 <a:latin typeface="Verdana"/>
               </a:rPr>
@@ -3861,7 +3861,7 @@
             <a:avLst/>
           </a:prstGeom>
           <a:solidFill>
-            <a:srgbClr val="1F7A8C"/>
+            <a:srgbClr val="0F8A86"/>
           </a:solidFill>
           <a:ln>
             <a:noFill/>
@@ -4017,7 +4017,7 @@
             <a:r>
               <a:rPr sz="1500" b="1">
                 <a:solidFill>
-                  <a:srgbClr val="1F7A8C"/>
+                  <a:srgbClr val="0F8A86"/>
                 </a:solidFill>
                 <a:latin typeface="Verdana"/>
               </a:rPr>
@@ -4118,7 +4118,7 @@
             <a:avLst/>
           </a:prstGeom>
           <a:solidFill>
-            <a:srgbClr val="1F7A8C"/>
+            <a:srgbClr val="0F8A86"/>
           </a:solidFill>
           <a:ln>
             <a:noFill/>
@@ -4210,7 +4210,7 @@
             <a:r>
               <a:rPr sz="1700" b="1">
                 <a:solidFill>
-                  <a:srgbClr val="1F7A8C"/>
+                  <a:srgbClr val="0F8A86"/>
                 </a:solidFill>
                 <a:latin typeface="Verdana"/>
               </a:rPr>
@@ -4242,7 +4242,7 @@
             <a:r>
               <a:rPr sz="1700" b="1">
                 <a:solidFill>
-                  <a:srgbClr val="1F7A8C"/>
+                  <a:srgbClr val="0F8A86"/>
                 </a:solidFill>
                 <a:latin typeface="Verdana"/>
               </a:rPr>
@@ -4274,7 +4274,7 @@
             <a:r>
               <a:rPr sz="1700" b="1">
                 <a:solidFill>
-                  <a:srgbClr val="1F7A8C"/>
+                  <a:srgbClr val="0F8A86"/>
                 </a:solidFill>
                 <a:latin typeface="Verdana"/>
               </a:rPr>
@@ -4383,7 +4383,7 @@
             <a:avLst/>
           </a:prstGeom>
           <a:solidFill>
-            <a:srgbClr val="1F7A8C"/>
+            <a:srgbClr val="0F8A86"/>
           </a:solidFill>
           <a:ln>
             <a:noFill/>
@@ -4475,7 +4475,7 @@
             <a:r>
               <a:rPr sz="1700" b="1">
                 <a:solidFill>
-                  <a:srgbClr val="1F7A8C"/>
+                  <a:srgbClr val="0F8A86"/>
                 </a:solidFill>
                 <a:latin typeface="Verdana"/>
               </a:rPr>
@@ -4507,7 +4507,7 @@
             <a:r>
               <a:rPr sz="1700" b="1">
                 <a:solidFill>
-                  <a:srgbClr val="1F7A8C"/>
+                  <a:srgbClr val="0F8A86"/>
                 </a:solidFill>
                 <a:latin typeface="Verdana"/>
               </a:rPr>
@@ -4539,7 +4539,7 @@
             <a:r>
               <a:rPr sz="1700" b="1">
                 <a:solidFill>
-                  <a:srgbClr val="1F7A8C"/>
+                  <a:srgbClr val="0F8A86"/>
                 </a:solidFill>
                 <a:latin typeface="Verdana"/>
               </a:rPr>

</xml_diff>